<commit_message>
Full cross-artifact consistency pass: align every number and claim
- Player-seasons 1,185 -> 1,208 everywhere (was hardcoded pre-data-growth):
  index.html, both dashboards, Excel, pptx, tableau guide, and 6 source scripts
- Remove overclaims that contradicted the Limitations content:
  "zero human/manual bias" and "mathematically proven optimal" -> honest wording
  (dashboards, pptx, sources)
- Synergy pair count 1,661 -> 1,645 (actual); K-Means "10 stats" -> 9 (DREB dropped)
- Regenerated dashboards, Excel, and slide deck from corrected sources with
  current data and current embedded charts

Co-Authored-By: Claude Opus 4.8 <noreply@anthropic.com>
</commit_message>
<xml_diff>
--- a/deliverables/presentation/NBA_Optimizer_Presentation.pptx
+++ b/deliverables/presentation/NBA_Optimizer_Presentation.pptx
@@ -5,27 +5,27 @@
     <p:sldMasterId id="2147483648" r:id="rId1"/>
   </p:sldMasterIdLst>
   <p:sldIdLst>
-    <p:sldId id="256" r:id="rId2"/>
-    <p:sldId id="257" r:id="rId3"/>
-    <p:sldId id="258" r:id="rId4"/>
-    <p:sldId id="259" r:id="rId5"/>
-    <p:sldId id="260" r:id="rId6"/>
-    <p:sldId id="261" r:id="rId7"/>
-    <p:sldId id="262" r:id="rId8"/>
-    <p:sldId id="263" r:id="rId9"/>
-    <p:sldId id="264" r:id="rId10"/>
-    <p:sldId id="265" r:id="rId11"/>
-    <p:sldId id="266" r:id="rId12"/>
-    <p:sldId id="267" r:id="rId13"/>
-    <p:sldId id="268" r:id="rId14"/>
-    <p:sldId id="269" r:id="rId15"/>
-    <p:sldId id="270" r:id="rId16"/>
-    <p:sldId id="271" r:id="rId17"/>
-    <p:sldId id="272" r:id="rId18"/>
-    <p:sldId id="273" r:id="rId19"/>
-    <p:sldId id="274" r:id="rId20"/>
+    <p:sldId id="256" r:id="rId7"/>
+    <p:sldId id="257" r:id="rId8"/>
+    <p:sldId id="258" r:id="rId9"/>
+    <p:sldId id="259" r:id="rId10"/>
+    <p:sldId id="260" r:id="rId11"/>
+    <p:sldId id="261" r:id="rId12"/>
+    <p:sldId id="262" r:id="rId13"/>
+    <p:sldId id="263" r:id="rId14"/>
+    <p:sldId id="264" r:id="rId15"/>
+    <p:sldId id="265" r:id="rId16"/>
+    <p:sldId id="266" r:id="rId17"/>
+    <p:sldId id="267" r:id="rId18"/>
+    <p:sldId id="268" r:id="rId19"/>
+    <p:sldId id="269" r:id="rId20"/>
+    <p:sldId id="270" r:id="rId21"/>
+    <p:sldId id="271" r:id="rId22"/>
+    <p:sldId id="272" r:id="rId23"/>
+    <p:sldId id="273" r:id="rId24"/>
+    <p:sldId id="274" r:id="rId25"/>
   </p:sldIdLst>
-  <p:sldSz cx="12192000" cy="6858000"/>
+  <p:sldSz cx="12191695" cy="6858000" type="screen4x3"/>
   <p:notesSz cx="6858000" cy="9144000"/>
   <p:defaultTextStyle>
     <a:defPPr>
@@ -122,60 +122,7 @@
       </a:defRPr>
     </a:lvl9pPr>
   </p:defaultTextStyle>
-  <p:extLst>
-    <p:ext uri="{EFAFB233-063F-42B5-8137-9DF3F51BA10A}">
-      <p15:sldGuideLst xmlns:p15="http://schemas.microsoft.com/office/powerpoint/2012/main">
-        <p15:guide id="1" orient="horz" pos="2160">
-          <p15:clr>
-            <a:srgbClr val="A4A3A4"/>
-          </p15:clr>
-        </p15:guide>
-        <p15:guide id="2" pos="2880">
-          <p15:clr>
-            <a:srgbClr val="A4A3A4"/>
-          </p15:clr>
-        </p15:guide>
-      </p15:sldGuideLst>
-    </p:ext>
-  </p:extLst>
 </p:presentation>
-</file>
-
-<file path=ppt/changesInfos/changesInfo1.xml><?xml version="1.0" encoding="utf-8"?>
-<pc:chgInfo xmlns:a="http://schemas.openxmlformats.org/drawingml/2006/main" xmlns:r="http://schemas.openxmlformats.org/officeDocument/2006/relationships" xmlns:ac="http://schemas.microsoft.com/office/drawing/2013/main/command" xmlns:pc="http://schemas.microsoft.com/office/powerpoint/2013/main/command">
-  <pc:docChgLst>
-    <pc:chgData name="Minho Moon" userId="b71dfef719442e0e" providerId="LiveId" clId="{8CD990A9-8A41-4B79-A2F7-DBE3003A1085}"/>
-    <pc:docChg chg="modSld">
-      <pc:chgData name="Minho Moon" userId="b71dfef719442e0e" providerId="LiveId" clId="{8CD990A9-8A41-4B79-A2F7-DBE3003A1085}" dt="2026-06-01T22:30:21.554" v="6" actId="14100"/>
-      <pc:docMkLst>
-        <pc:docMk/>
-      </pc:docMkLst>
-      <pc:sldChg chg="modSp mod">
-        <pc:chgData name="Minho Moon" userId="b71dfef719442e0e" providerId="LiveId" clId="{8CD990A9-8A41-4B79-A2F7-DBE3003A1085}" dt="2026-06-01T22:30:21.554" v="6" actId="14100"/>
-        <pc:sldMkLst>
-          <pc:docMk/>
-          <pc:sldMk cId="0" sldId="264"/>
-        </pc:sldMkLst>
-        <pc:picChg chg="mod">
-          <ac:chgData name="Minho Moon" userId="b71dfef719442e0e" providerId="LiveId" clId="{8CD990A9-8A41-4B79-A2F7-DBE3003A1085}" dt="2026-06-01T22:30:21.554" v="6" actId="14100"/>
-          <ac:picMkLst>
-            <pc:docMk/>
-            <pc:sldMk cId="0" sldId="264"/>
-            <ac:picMk id="4" creationId="{00000000-0000-0000-0000-000000000000}"/>
-          </ac:picMkLst>
-        </pc:picChg>
-        <pc:picChg chg="mod">
-          <ac:chgData name="Minho Moon" userId="b71dfef719442e0e" providerId="LiveId" clId="{8CD990A9-8A41-4B79-A2F7-DBE3003A1085}" dt="2026-06-01T22:30:15.524" v="4" actId="14100"/>
-          <ac:picMkLst>
-            <pc:docMk/>
-            <pc:sldMk cId="0" sldId="264"/>
-            <ac:picMk id="5" creationId="{00000000-0000-0000-0000-000000000000}"/>
-          </ac:picMkLst>
-        </pc:picChg>
-      </pc:sldChg>
-    </pc:docChg>
-  </pc:docChgLst>
-</pc:chgInfo>
 </file>
 
 <file path=ppt/slideLayouts/slideLayout1.xml><?xml version="1.0" encoding="utf-8"?>
@@ -216,9 +163,10 @@
           <a:lstStyle/>
           <a:p>
             <a:r>
-              <a:rPr lang="en-US"/>
+              <a:rPr lang="en-US" smtClean="0"/>
               <a:t>Click to edit Master title style</a:t>
             </a:r>
+            <a:endParaRPr lang="en-US"/>
           </a:p>
         </p:txBody>
       </p:sp>
@@ -334,9 +282,10 @@
           </a:lstStyle>
           <a:p>
             <a:r>
-              <a:rPr lang="en-US"/>
+              <a:rPr lang="en-US" smtClean="0"/>
               <a:t>Click to edit Master subtitle style</a:t>
             </a:r>
+            <a:endParaRPr lang="en-US"/>
           </a:p>
         </p:txBody>
       </p:sp>
@@ -357,7 +306,7 @@
           <a:p>
             <a:fld id="{5BCAD085-E8A6-8845-BD4E-CB4CCA059FC4}" type="datetimeFigureOut">
               <a:rPr lang="en-US" smtClean="0"/>
-              <a:t>6/1/2026</a:t>
+              <a:t>1/27/13</a:t>
             </a:fld>
             <a:endParaRPr lang="en-US"/>
           </a:p>
@@ -451,9 +400,10 @@
           <a:lstStyle/>
           <a:p>
             <a:r>
-              <a:rPr lang="en-US"/>
+              <a:rPr lang="en-US" smtClean="0"/>
               <a:t>Click to edit Master title style</a:t>
             </a:r>
+            <a:endParaRPr lang="en-US"/>
           </a:p>
         </p:txBody>
       </p:sp>
@@ -474,37 +424,38 @@
           <a:p>
             <a:pPr lvl="0"/>
             <a:r>
-              <a:rPr lang="en-US"/>
+              <a:rPr lang="en-US" smtClean="0"/>
               <a:t>Click to edit Master text styles</a:t>
             </a:r>
           </a:p>
           <a:p>
             <a:pPr lvl="1"/>
             <a:r>
-              <a:rPr lang="en-US"/>
+              <a:rPr lang="en-US" smtClean="0"/>
               <a:t>Second level</a:t>
             </a:r>
           </a:p>
           <a:p>
             <a:pPr lvl="2"/>
             <a:r>
-              <a:rPr lang="en-US"/>
+              <a:rPr lang="en-US" smtClean="0"/>
               <a:t>Third level</a:t>
             </a:r>
           </a:p>
           <a:p>
             <a:pPr lvl="3"/>
             <a:r>
-              <a:rPr lang="en-US"/>
+              <a:rPr lang="en-US" smtClean="0"/>
               <a:t>Fourth level</a:t>
             </a:r>
           </a:p>
           <a:p>
             <a:pPr lvl="4"/>
             <a:r>
-              <a:rPr lang="en-US"/>
+              <a:rPr lang="en-US" smtClean="0"/>
               <a:t>Fifth level</a:t>
             </a:r>
+            <a:endParaRPr lang="en-US"/>
           </a:p>
         </p:txBody>
       </p:sp>
@@ -525,7 +476,7 @@
           <a:p>
             <a:fld id="{5BCAD085-E8A6-8845-BD4E-CB4CCA059FC4}" type="datetimeFigureOut">
               <a:rPr lang="en-US" smtClean="0"/>
-              <a:t>6/1/2026</a:t>
+              <a:t>1/27/13</a:t>
             </a:fld>
             <a:endParaRPr lang="en-US"/>
           </a:p>
@@ -624,9 +575,10 @@
           <a:lstStyle/>
           <a:p>
             <a:r>
-              <a:rPr lang="en-US"/>
+              <a:rPr lang="en-US" smtClean="0"/>
               <a:t>Click to edit Master title style</a:t>
             </a:r>
+            <a:endParaRPr lang="en-US"/>
           </a:p>
         </p:txBody>
       </p:sp>
@@ -652,37 +604,38 @@
           <a:p>
             <a:pPr lvl="0"/>
             <a:r>
-              <a:rPr lang="en-US"/>
+              <a:rPr lang="en-US" smtClean="0"/>
               <a:t>Click to edit Master text styles</a:t>
             </a:r>
           </a:p>
           <a:p>
             <a:pPr lvl="1"/>
             <a:r>
-              <a:rPr lang="en-US"/>
+              <a:rPr lang="en-US" smtClean="0"/>
               <a:t>Second level</a:t>
             </a:r>
           </a:p>
           <a:p>
             <a:pPr lvl="2"/>
             <a:r>
-              <a:rPr lang="en-US"/>
+              <a:rPr lang="en-US" smtClean="0"/>
               <a:t>Third level</a:t>
             </a:r>
           </a:p>
           <a:p>
             <a:pPr lvl="3"/>
             <a:r>
-              <a:rPr lang="en-US"/>
+              <a:rPr lang="en-US" smtClean="0"/>
               <a:t>Fourth level</a:t>
             </a:r>
           </a:p>
           <a:p>
             <a:pPr lvl="4"/>
             <a:r>
-              <a:rPr lang="en-US"/>
+              <a:rPr lang="en-US" smtClean="0"/>
               <a:t>Fifth level</a:t>
             </a:r>
+            <a:endParaRPr lang="en-US"/>
           </a:p>
         </p:txBody>
       </p:sp>
@@ -703,7 +656,7 @@
           <a:p>
             <a:fld id="{5BCAD085-E8A6-8845-BD4E-CB4CCA059FC4}" type="datetimeFigureOut">
               <a:rPr lang="en-US" smtClean="0"/>
-              <a:t>6/1/2026</a:t>
+              <a:t>1/27/13</a:t>
             </a:fld>
             <a:endParaRPr lang="en-US"/>
           </a:p>
@@ -797,9 +750,10 @@
           <a:lstStyle/>
           <a:p>
             <a:r>
-              <a:rPr lang="en-US"/>
+              <a:rPr lang="en-US" smtClean="0"/>
               <a:t>Click to edit Master title style</a:t>
             </a:r>
+            <a:endParaRPr lang="en-US"/>
           </a:p>
         </p:txBody>
       </p:sp>
@@ -820,37 +774,38 @@
           <a:p>
             <a:pPr lvl="0"/>
             <a:r>
-              <a:rPr lang="en-US"/>
+              <a:rPr lang="en-US" smtClean="0"/>
               <a:t>Click to edit Master text styles</a:t>
             </a:r>
           </a:p>
           <a:p>
             <a:pPr lvl="1"/>
             <a:r>
-              <a:rPr lang="en-US"/>
+              <a:rPr lang="en-US" smtClean="0"/>
               <a:t>Second level</a:t>
             </a:r>
           </a:p>
           <a:p>
             <a:pPr lvl="2"/>
             <a:r>
-              <a:rPr lang="en-US"/>
+              <a:rPr lang="en-US" smtClean="0"/>
               <a:t>Third level</a:t>
             </a:r>
           </a:p>
           <a:p>
             <a:pPr lvl="3"/>
             <a:r>
-              <a:rPr lang="en-US"/>
+              <a:rPr lang="en-US" smtClean="0"/>
               <a:t>Fourth level</a:t>
             </a:r>
           </a:p>
           <a:p>
             <a:pPr lvl="4"/>
             <a:r>
-              <a:rPr lang="en-US"/>
+              <a:rPr lang="en-US" smtClean="0"/>
               <a:t>Fifth level</a:t>
             </a:r>
+            <a:endParaRPr lang="en-US"/>
           </a:p>
         </p:txBody>
       </p:sp>
@@ -871,7 +826,7 @@
           <a:p>
             <a:fld id="{5BCAD085-E8A6-8845-BD4E-CB4CCA059FC4}" type="datetimeFigureOut">
               <a:rPr lang="en-US" smtClean="0"/>
-              <a:t>6/1/2026</a:t>
+              <a:t>1/27/13</a:t>
             </a:fld>
             <a:endParaRPr lang="en-US"/>
           </a:p>
@@ -974,9 +929,10 @@
           </a:lstStyle>
           <a:p>
             <a:r>
-              <a:rPr lang="en-US"/>
+              <a:rPr lang="en-US" smtClean="0"/>
               <a:t>Click to edit Master title style</a:t>
             </a:r>
+            <a:endParaRPr lang="en-US"/>
           </a:p>
         </p:txBody>
       </p:sp>
@@ -1093,7 +1049,7 @@
           <a:p>
             <a:pPr lvl="0"/>
             <a:r>
-              <a:rPr lang="en-US"/>
+              <a:rPr lang="en-US" smtClean="0"/>
               <a:t>Click to edit Master text styles</a:t>
             </a:r>
           </a:p>
@@ -1116,7 +1072,7 @@
           <a:p>
             <a:fld id="{5BCAD085-E8A6-8845-BD4E-CB4CCA059FC4}" type="datetimeFigureOut">
               <a:rPr lang="en-US" smtClean="0"/>
-              <a:t>6/1/2026</a:t>
+              <a:t>1/27/13</a:t>
             </a:fld>
             <a:endParaRPr lang="en-US"/>
           </a:p>
@@ -1210,9 +1166,10 @@
           <a:lstStyle/>
           <a:p>
             <a:r>
-              <a:rPr lang="en-US"/>
+              <a:rPr lang="en-US" smtClean="0"/>
               <a:t>Click to edit Master title style</a:t>
             </a:r>
+            <a:endParaRPr lang="en-US"/>
           </a:p>
         </p:txBody>
       </p:sp>
@@ -1266,37 +1223,38 @@
           <a:p>
             <a:pPr lvl="0"/>
             <a:r>
-              <a:rPr lang="en-US"/>
+              <a:rPr lang="en-US" smtClean="0"/>
               <a:t>Click to edit Master text styles</a:t>
             </a:r>
           </a:p>
           <a:p>
             <a:pPr lvl="1"/>
             <a:r>
-              <a:rPr lang="en-US"/>
+              <a:rPr lang="en-US" smtClean="0"/>
               <a:t>Second level</a:t>
             </a:r>
           </a:p>
           <a:p>
             <a:pPr lvl="2"/>
             <a:r>
-              <a:rPr lang="en-US"/>
+              <a:rPr lang="en-US" smtClean="0"/>
               <a:t>Third level</a:t>
             </a:r>
           </a:p>
           <a:p>
             <a:pPr lvl="3"/>
             <a:r>
-              <a:rPr lang="en-US"/>
+              <a:rPr lang="en-US" smtClean="0"/>
               <a:t>Fourth level</a:t>
             </a:r>
           </a:p>
           <a:p>
             <a:pPr lvl="4"/>
             <a:r>
-              <a:rPr lang="en-US"/>
+              <a:rPr lang="en-US" smtClean="0"/>
               <a:t>Fifth level</a:t>
             </a:r>
+            <a:endParaRPr lang="en-US"/>
           </a:p>
         </p:txBody>
       </p:sp>
@@ -1350,37 +1308,38 @@
           <a:p>
             <a:pPr lvl="0"/>
             <a:r>
-              <a:rPr lang="en-US"/>
+              <a:rPr lang="en-US" smtClean="0"/>
               <a:t>Click to edit Master text styles</a:t>
             </a:r>
           </a:p>
           <a:p>
             <a:pPr lvl="1"/>
             <a:r>
-              <a:rPr lang="en-US"/>
+              <a:rPr lang="en-US" smtClean="0"/>
               <a:t>Second level</a:t>
             </a:r>
           </a:p>
           <a:p>
             <a:pPr lvl="2"/>
             <a:r>
-              <a:rPr lang="en-US"/>
+              <a:rPr lang="en-US" smtClean="0"/>
               <a:t>Third level</a:t>
             </a:r>
           </a:p>
           <a:p>
             <a:pPr lvl="3"/>
             <a:r>
-              <a:rPr lang="en-US"/>
+              <a:rPr lang="en-US" smtClean="0"/>
               <a:t>Fourth level</a:t>
             </a:r>
           </a:p>
           <a:p>
             <a:pPr lvl="4"/>
             <a:r>
-              <a:rPr lang="en-US"/>
+              <a:rPr lang="en-US" smtClean="0"/>
               <a:t>Fifth level</a:t>
             </a:r>
+            <a:endParaRPr lang="en-US"/>
           </a:p>
         </p:txBody>
       </p:sp>
@@ -1401,7 +1360,7 @@
           <a:p>
             <a:fld id="{5BCAD085-E8A6-8845-BD4E-CB4CCA059FC4}" type="datetimeFigureOut">
               <a:rPr lang="en-US" smtClean="0"/>
-              <a:t>6/1/2026</a:t>
+              <a:t>1/27/13</a:t>
             </a:fld>
             <a:endParaRPr lang="en-US"/>
           </a:p>
@@ -1499,9 +1458,10 @@
           </a:lstStyle>
           <a:p>
             <a:r>
-              <a:rPr lang="en-US"/>
+              <a:rPr lang="en-US" smtClean="0"/>
               <a:t>Click to edit Master title style</a:t>
             </a:r>
+            <a:endParaRPr lang="en-US"/>
           </a:p>
         </p:txBody>
       </p:sp>
@@ -1564,7 +1524,7 @@
           <a:p>
             <a:pPr lvl="0"/>
             <a:r>
-              <a:rPr lang="en-US"/>
+              <a:rPr lang="en-US" smtClean="0"/>
               <a:t>Click to edit Master text styles</a:t>
             </a:r>
           </a:p>
@@ -1620,37 +1580,38 @@
           <a:p>
             <a:pPr lvl="0"/>
             <a:r>
-              <a:rPr lang="en-US"/>
+              <a:rPr lang="en-US" smtClean="0"/>
               <a:t>Click to edit Master text styles</a:t>
             </a:r>
           </a:p>
           <a:p>
             <a:pPr lvl="1"/>
             <a:r>
-              <a:rPr lang="en-US"/>
+              <a:rPr lang="en-US" smtClean="0"/>
               <a:t>Second level</a:t>
             </a:r>
           </a:p>
           <a:p>
             <a:pPr lvl="2"/>
             <a:r>
-              <a:rPr lang="en-US"/>
+              <a:rPr lang="en-US" smtClean="0"/>
               <a:t>Third level</a:t>
             </a:r>
           </a:p>
           <a:p>
             <a:pPr lvl="3"/>
             <a:r>
-              <a:rPr lang="en-US"/>
+              <a:rPr lang="en-US" smtClean="0"/>
               <a:t>Fourth level</a:t>
             </a:r>
           </a:p>
           <a:p>
             <a:pPr lvl="4"/>
             <a:r>
-              <a:rPr lang="en-US"/>
+              <a:rPr lang="en-US" smtClean="0"/>
               <a:t>Fifth level</a:t>
             </a:r>
+            <a:endParaRPr lang="en-US"/>
           </a:p>
         </p:txBody>
       </p:sp>
@@ -1713,7 +1674,7 @@
           <a:p>
             <a:pPr lvl="0"/>
             <a:r>
-              <a:rPr lang="en-US"/>
+              <a:rPr lang="en-US" smtClean="0"/>
               <a:t>Click to edit Master text styles</a:t>
             </a:r>
           </a:p>
@@ -1769,37 +1730,38 @@
           <a:p>
             <a:pPr lvl="0"/>
             <a:r>
-              <a:rPr lang="en-US"/>
+              <a:rPr lang="en-US" smtClean="0"/>
               <a:t>Click to edit Master text styles</a:t>
             </a:r>
           </a:p>
           <a:p>
             <a:pPr lvl="1"/>
             <a:r>
-              <a:rPr lang="en-US"/>
+              <a:rPr lang="en-US" smtClean="0"/>
               <a:t>Second level</a:t>
             </a:r>
           </a:p>
           <a:p>
             <a:pPr lvl="2"/>
             <a:r>
-              <a:rPr lang="en-US"/>
+              <a:rPr lang="en-US" smtClean="0"/>
               <a:t>Third level</a:t>
             </a:r>
           </a:p>
           <a:p>
             <a:pPr lvl="3"/>
             <a:r>
-              <a:rPr lang="en-US"/>
+              <a:rPr lang="en-US" smtClean="0"/>
               <a:t>Fourth level</a:t>
             </a:r>
           </a:p>
           <a:p>
             <a:pPr lvl="4"/>
             <a:r>
-              <a:rPr lang="en-US"/>
+              <a:rPr lang="en-US" smtClean="0"/>
               <a:t>Fifth level</a:t>
             </a:r>
+            <a:endParaRPr lang="en-US"/>
           </a:p>
         </p:txBody>
       </p:sp>
@@ -1820,7 +1782,7 @@
           <a:p>
             <a:fld id="{5BCAD085-E8A6-8845-BD4E-CB4CCA059FC4}" type="datetimeFigureOut">
               <a:rPr lang="en-US" smtClean="0"/>
-              <a:t>6/1/2026</a:t>
+              <a:t>1/27/13</a:t>
             </a:fld>
             <a:endParaRPr lang="en-US"/>
           </a:p>
@@ -1914,9 +1876,10 @@
           <a:lstStyle/>
           <a:p>
             <a:r>
-              <a:rPr lang="en-US"/>
+              <a:rPr lang="en-US" smtClean="0"/>
               <a:t>Click to edit Master title style</a:t>
             </a:r>
+            <a:endParaRPr lang="en-US"/>
           </a:p>
         </p:txBody>
       </p:sp>
@@ -1937,7 +1900,7 @@
           <a:p>
             <a:fld id="{5BCAD085-E8A6-8845-BD4E-CB4CCA059FC4}" type="datetimeFigureOut">
               <a:rPr lang="en-US" smtClean="0"/>
-              <a:t>6/1/2026</a:t>
+              <a:t>1/27/13</a:t>
             </a:fld>
             <a:endParaRPr lang="en-US"/>
           </a:p>
@@ -2032,7 +1995,7 @@
           <a:p>
             <a:fld id="{5BCAD085-E8A6-8845-BD4E-CB4CCA059FC4}" type="datetimeFigureOut">
               <a:rPr lang="en-US" smtClean="0"/>
-              <a:t>6/1/2026</a:t>
+              <a:t>1/27/13</a:t>
             </a:fld>
             <a:endParaRPr lang="en-US"/>
           </a:p>
@@ -2135,9 +2098,10 @@
           </a:lstStyle>
           <a:p>
             <a:r>
-              <a:rPr lang="en-US"/>
+              <a:rPr lang="en-US" smtClean="0"/>
               <a:t>Click to edit Master title style</a:t>
             </a:r>
+            <a:endParaRPr lang="en-US"/>
           </a:p>
         </p:txBody>
       </p:sp>
@@ -2191,37 +2155,38 @@
           <a:p>
             <a:pPr lvl="0"/>
             <a:r>
-              <a:rPr lang="en-US"/>
+              <a:rPr lang="en-US" smtClean="0"/>
               <a:t>Click to edit Master text styles</a:t>
             </a:r>
           </a:p>
           <a:p>
             <a:pPr lvl="1"/>
             <a:r>
-              <a:rPr lang="en-US"/>
+              <a:rPr lang="en-US" smtClean="0"/>
               <a:t>Second level</a:t>
             </a:r>
           </a:p>
           <a:p>
             <a:pPr lvl="2"/>
             <a:r>
-              <a:rPr lang="en-US"/>
+              <a:rPr lang="en-US" smtClean="0"/>
               <a:t>Third level</a:t>
             </a:r>
           </a:p>
           <a:p>
             <a:pPr lvl="3"/>
             <a:r>
-              <a:rPr lang="en-US"/>
+              <a:rPr lang="en-US" smtClean="0"/>
               <a:t>Fourth level</a:t>
             </a:r>
           </a:p>
           <a:p>
             <a:pPr lvl="4"/>
             <a:r>
-              <a:rPr lang="en-US"/>
+              <a:rPr lang="en-US" smtClean="0"/>
               <a:t>Fifth level</a:t>
             </a:r>
+            <a:endParaRPr lang="en-US"/>
           </a:p>
         </p:txBody>
       </p:sp>
@@ -2284,7 +2249,7 @@
           <a:p>
             <a:pPr lvl="0"/>
             <a:r>
-              <a:rPr lang="en-US"/>
+              <a:rPr lang="en-US" smtClean="0"/>
               <a:t>Click to edit Master text styles</a:t>
             </a:r>
           </a:p>
@@ -2307,7 +2272,7 @@
           <a:p>
             <a:fld id="{5BCAD085-E8A6-8845-BD4E-CB4CCA059FC4}" type="datetimeFigureOut">
               <a:rPr lang="en-US" smtClean="0"/>
-              <a:t>6/1/2026</a:t>
+              <a:t>1/27/13</a:t>
             </a:fld>
             <a:endParaRPr lang="en-US"/>
           </a:p>
@@ -2410,9 +2375,10 @@
           </a:lstStyle>
           <a:p>
             <a:r>
-              <a:rPr lang="en-US"/>
+              <a:rPr lang="en-US" smtClean="0"/>
               <a:t>Click to edit Master title style</a:t>
             </a:r>
+            <a:endParaRPr lang="en-US"/>
           </a:p>
         </p:txBody>
       </p:sp>
@@ -2536,7 +2502,7 @@
           <a:p>
             <a:pPr lvl="0"/>
             <a:r>
-              <a:rPr lang="en-US"/>
+              <a:rPr lang="en-US" smtClean="0"/>
               <a:t>Click to edit Master text styles</a:t>
             </a:r>
           </a:p>
@@ -2559,7 +2525,7 @@
           <a:p>
             <a:fld id="{5BCAD085-E8A6-8845-BD4E-CB4CCA059FC4}" type="datetimeFigureOut">
               <a:rPr lang="en-US" smtClean="0"/>
-              <a:t>6/1/2026</a:t>
+              <a:t>1/27/13</a:t>
             </a:fld>
             <a:endParaRPr lang="en-US"/>
           </a:p>
@@ -2668,9 +2634,10 @@
           <a:lstStyle/>
           <a:p>
             <a:r>
-              <a:rPr lang="en-US"/>
+              <a:rPr lang="en-US" smtClean="0"/>
               <a:t>Click to edit Master title style</a:t>
             </a:r>
+            <a:endParaRPr lang="en-US"/>
           </a:p>
         </p:txBody>
       </p:sp>
@@ -2701,37 +2668,38 @@
           <a:p>
             <a:pPr lvl="0"/>
             <a:r>
-              <a:rPr lang="en-US"/>
+              <a:rPr lang="en-US" smtClean="0"/>
               <a:t>Click to edit Master text styles</a:t>
             </a:r>
           </a:p>
           <a:p>
             <a:pPr lvl="1"/>
             <a:r>
-              <a:rPr lang="en-US"/>
+              <a:rPr lang="en-US" smtClean="0"/>
               <a:t>Second level</a:t>
             </a:r>
           </a:p>
           <a:p>
             <a:pPr lvl="2"/>
             <a:r>
-              <a:rPr lang="en-US"/>
+              <a:rPr lang="en-US" smtClean="0"/>
               <a:t>Third level</a:t>
             </a:r>
           </a:p>
           <a:p>
             <a:pPr lvl="3"/>
             <a:r>
-              <a:rPr lang="en-US"/>
+              <a:rPr lang="en-US" smtClean="0"/>
               <a:t>Fourth level</a:t>
             </a:r>
           </a:p>
           <a:p>
             <a:pPr lvl="4"/>
             <a:r>
-              <a:rPr lang="en-US"/>
+              <a:rPr lang="en-US" smtClean="0"/>
               <a:t>Fifth level</a:t>
             </a:r>
+            <a:endParaRPr lang="en-US"/>
           </a:p>
         </p:txBody>
       </p:sp>
@@ -2770,7 +2738,7 @@
           <a:p>
             <a:fld id="{5BCAD085-E8A6-8845-BD4E-CB4CCA059FC4}" type="datetimeFigureOut">
               <a:rPr lang="en-US" smtClean="0"/>
-              <a:t>6/1/2026</a:t>
+              <a:t>1/27/13</a:t>
             </a:fld>
             <a:endParaRPr lang="en-US"/>
           </a:p>
@@ -3129,7 +3097,7 @@
 </file>
 
 <file path=ppt/slides/slide1.xml><?xml version="1.0" encoding="utf-8"?>
-<p:sld xmlns:a="http://schemas.openxmlformats.org/drawingml/2006/main" xmlns:r="http://schemas.openxmlformats.org/officeDocument/2006/relationships" xmlns:p="http://schemas.openxmlformats.org/presentationml/2006/main">
+<p:sld xmlns:a="http://schemas.openxmlformats.org/drawingml/2006/main" xmlns:p="http://schemas.openxmlformats.org/presentationml/2006/main" xmlns:r="http://schemas.openxmlformats.org/officeDocument/2006/relationships">
   <p:cSld>
     <p:bg>
       <p:bgPr>
@@ -3145,14 +3113,7 @@
         <p:cNvGrpSpPr/>
         <p:nvPr/>
       </p:nvGrpSpPr>
-      <p:grpSpPr>
-        <a:xfrm>
-          <a:off x="0" y="0"/>
-          <a:ext cx="0" cy="0"/>
-          <a:chOff x="0" y="0"/>
-          <a:chExt cx="0" cy="0"/>
-        </a:xfrm>
-      </p:grpSpPr>
+      <p:grpSpPr/>
       <p:sp>
         <p:nvSpPr>
           <p:cNvPr id="2" name="TextBox 1"/>
@@ -3292,7 +3253,7 @@
               </a:defRPr>
             </a:pPr>
             <a:r>
-              <a:t>1,185 Player-Seasons  |  9 Validated Stats  |  6 Archetypes  |  10 Optimized Rosters</a:t>
+              <a:t>1,208 Player-Seasons  |  9 Validated Stats  |  6 Archetypes  |  10 Optimized Rosters</a:t>
             </a:r>
           </a:p>
         </p:txBody>
@@ -3306,7 +3267,7 @@
 </file>
 
 <file path=ppt/slides/slide10.xml><?xml version="1.0" encoding="utf-8"?>
-<p:sld xmlns:a="http://schemas.openxmlformats.org/drawingml/2006/main" xmlns:r="http://schemas.openxmlformats.org/officeDocument/2006/relationships" xmlns:p="http://schemas.openxmlformats.org/presentationml/2006/main">
+<p:sld xmlns:a="http://schemas.openxmlformats.org/drawingml/2006/main" xmlns:p="http://schemas.openxmlformats.org/presentationml/2006/main" xmlns:r="http://schemas.openxmlformats.org/officeDocument/2006/relationships">
   <p:cSld>
     <p:bg>
       <p:bgPr>
@@ -3322,14 +3283,7 @@
         <p:cNvGrpSpPr/>
         <p:nvPr/>
       </p:nvGrpSpPr>
-      <p:grpSpPr>
-        <a:xfrm>
-          <a:off x="0" y="0"/>
-          <a:ext cx="0" cy="0"/>
-          <a:chOff x="0" y="0"/>
-          <a:chExt cx="0" cy="0"/>
-        </a:xfrm>
-      </p:grpSpPr>
+      <p:grpSpPr/>
       <p:sp>
         <p:nvSpPr>
           <p:cNvPr id="2" name="TextBox 1"/>
@@ -3435,7 +3389,7 @@
 </file>
 
 <file path=ppt/slides/slide11.xml><?xml version="1.0" encoding="utf-8"?>
-<p:sld xmlns:a="http://schemas.openxmlformats.org/drawingml/2006/main" xmlns:r="http://schemas.openxmlformats.org/officeDocument/2006/relationships" xmlns:p="http://schemas.openxmlformats.org/presentationml/2006/main">
+<p:sld xmlns:a="http://schemas.openxmlformats.org/drawingml/2006/main" xmlns:p="http://schemas.openxmlformats.org/presentationml/2006/main" xmlns:r="http://schemas.openxmlformats.org/officeDocument/2006/relationships">
   <p:cSld>
     <p:bg>
       <p:bgPr>
@@ -3451,14 +3405,7 @@
         <p:cNvGrpSpPr/>
         <p:nvPr/>
       </p:nvGrpSpPr>
-      <p:grpSpPr>
-        <a:xfrm>
-          <a:off x="0" y="0"/>
-          <a:ext cx="0" cy="0"/>
-          <a:chOff x="0" y="0"/>
-          <a:chExt cx="0" cy="0"/>
-        </a:xfrm>
-      </p:grpSpPr>
+      <p:grpSpPr/>
       <p:sp>
         <p:nvSpPr>
           <p:cNvPr id="2" name="TextBox 1"/>
@@ -3529,7 +3476,7 @@
               </a:defRPr>
             </a:pPr>
             <a:r>
-              <a:t>MILP (Mixed Integer Linear Programming): mathematically proven optimal solution, not heuristic</a:t>
+              <a:t>MILP (Mixed Integer Linear Programming): mathematically optimal solution to the stated objective (exact, not a heuristic)</a:t>
             </a:r>
           </a:p>
           <a:p>
@@ -3576,7 +3523,6 @@
                 <a:latin typeface="Calibri"/>
               </a:defRPr>
             </a:pPr>
-            <a:endParaRPr/>
           </a:p>
           <a:p>
             <a:pPr>
@@ -3686,7 +3632,6 @@
                 <a:latin typeface="Calibri"/>
               </a:defRPr>
             </a:pPr>
-            <a:endParaRPr/>
           </a:p>
           <a:p>
             <a:pPr>
@@ -3779,7 +3724,7 @@
 </file>
 
 <file path=ppt/slides/slide12.xml><?xml version="1.0" encoding="utf-8"?>
-<p:sld xmlns:a="http://schemas.openxmlformats.org/drawingml/2006/main" xmlns:r="http://schemas.openxmlformats.org/officeDocument/2006/relationships" xmlns:p="http://schemas.openxmlformats.org/presentationml/2006/main">
+<p:sld xmlns:a="http://schemas.openxmlformats.org/drawingml/2006/main" xmlns:p="http://schemas.openxmlformats.org/presentationml/2006/main" xmlns:r="http://schemas.openxmlformats.org/officeDocument/2006/relationships">
   <p:cSld>
     <p:bg>
       <p:bgPr>
@@ -3795,14 +3740,7 @@
         <p:cNvGrpSpPr/>
         <p:nvPr/>
       </p:nvGrpSpPr>
-      <p:grpSpPr>
-        <a:xfrm>
-          <a:off x="0" y="0"/>
-          <a:ext cx="0" cy="0"/>
-          <a:chOff x="0" y="0"/>
-          <a:chExt cx="0" cy="0"/>
-        </a:xfrm>
-      </p:grpSpPr>
+      <p:grpSpPr/>
       <p:sp>
         <p:nvSpPr>
           <p:cNvPr id="2" name="TextBox 1"/>
@@ -3904,7 +3842,6 @@
                 <a:latin typeface="Calibri"/>
               </a:defRPr>
             </a:pPr>
-            <a:endParaRPr/>
           </a:p>
           <a:p>
             <a:pPr>
@@ -3934,7 +3871,6 @@
                 <a:latin typeface="Calibri"/>
               </a:defRPr>
             </a:pPr>
-            <a:endParaRPr/>
           </a:p>
           <a:p>
             <a:pPr>
@@ -3980,7 +3916,6 @@
                 <a:latin typeface="Calibri"/>
               </a:defRPr>
             </a:pPr>
-            <a:endParaRPr/>
           </a:p>
           <a:p>
             <a:pPr>
@@ -4026,7 +3961,6 @@
                 <a:latin typeface="Calibri"/>
               </a:defRPr>
             </a:pPr>
-            <a:endParaRPr/>
           </a:p>
           <a:p>
             <a:pPr>
@@ -4072,7 +4006,6 @@
                 <a:latin typeface="Calibri"/>
               </a:defRPr>
             </a:pPr>
-            <a:endParaRPr/>
           </a:p>
           <a:p>
             <a:pPr>
@@ -4117,7 +4050,7 @@
 </file>
 
 <file path=ppt/slides/slide13.xml><?xml version="1.0" encoding="utf-8"?>
-<p:sld xmlns:a="http://schemas.openxmlformats.org/drawingml/2006/main" xmlns:r="http://schemas.openxmlformats.org/officeDocument/2006/relationships" xmlns:p="http://schemas.openxmlformats.org/presentationml/2006/main">
+<p:sld xmlns:a="http://schemas.openxmlformats.org/drawingml/2006/main" xmlns:p="http://schemas.openxmlformats.org/presentationml/2006/main" xmlns:r="http://schemas.openxmlformats.org/officeDocument/2006/relationships">
   <p:cSld>
     <p:bg>
       <p:bgPr>
@@ -4133,14 +4066,7 @@
         <p:cNvGrpSpPr/>
         <p:nvPr/>
       </p:nvGrpSpPr>
-      <p:grpSpPr>
-        <a:xfrm>
-          <a:off x="0" y="0"/>
-          <a:ext cx="0" cy="0"/>
-          <a:chOff x="0" y="0"/>
-          <a:chExt cx="0" cy="0"/>
-        </a:xfrm>
-      </p:grpSpPr>
+      <p:grpSpPr/>
       <p:sp>
         <p:nvSpPr>
           <p:cNvPr id="2" name="TextBox 1"/>
@@ -4247,7 +4173,6 @@
               <a:t>Scenario J — Value / Efficiency        Maximize VORPD (Moneyball)</a:t>
             </a:r>
             <a:br/>
-            <a:endParaRPr/>
           </a:p>
         </p:txBody>
       </p:sp>
@@ -4300,7 +4225,7 @@
 </file>
 
 <file path=ppt/slides/slide14.xml><?xml version="1.0" encoding="utf-8"?>
-<p:sld xmlns:a="http://schemas.openxmlformats.org/drawingml/2006/main" xmlns:r="http://schemas.openxmlformats.org/officeDocument/2006/relationships" xmlns:p="http://schemas.openxmlformats.org/presentationml/2006/main">
+<p:sld xmlns:a="http://schemas.openxmlformats.org/drawingml/2006/main" xmlns:p="http://schemas.openxmlformats.org/presentationml/2006/main" xmlns:r="http://schemas.openxmlformats.org/officeDocument/2006/relationships">
   <p:cSld>
     <p:bg>
       <p:bgPr>
@@ -4316,14 +4241,7 @@
         <p:cNvGrpSpPr/>
         <p:nvPr/>
       </p:nvGrpSpPr>
-      <p:grpSpPr>
-        <a:xfrm>
-          <a:off x="0" y="0"/>
-          <a:ext cx="0" cy="0"/>
-          <a:chOff x="0" y="0"/>
-          <a:chExt cx="0" cy="0"/>
-        </a:xfrm>
-      </p:grpSpPr>
+      <p:grpSpPr/>
       <p:sp>
         <p:nvSpPr>
           <p:cNvPr id="2" name="TextBox 1"/>
@@ -4474,7 +4392,7 @@
 </file>
 
 <file path=ppt/slides/slide15.xml><?xml version="1.0" encoding="utf-8"?>
-<p:sld xmlns:a="http://schemas.openxmlformats.org/drawingml/2006/main" xmlns:r="http://schemas.openxmlformats.org/officeDocument/2006/relationships" xmlns:p="http://schemas.openxmlformats.org/presentationml/2006/main">
+<p:sld xmlns:a="http://schemas.openxmlformats.org/drawingml/2006/main" xmlns:p="http://schemas.openxmlformats.org/presentationml/2006/main" xmlns:r="http://schemas.openxmlformats.org/officeDocument/2006/relationships">
   <p:cSld>
     <p:bg>
       <p:bgPr>
@@ -4490,14 +4408,7 @@
         <p:cNvGrpSpPr/>
         <p:nvPr/>
       </p:nvGrpSpPr>
-      <p:grpSpPr>
-        <a:xfrm>
-          <a:off x="0" y="0"/>
-          <a:ext cx="0" cy="0"/>
-          <a:chOff x="0" y="0"/>
-          <a:chExt cx="0" cy="0"/>
-        </a:xfrm>
-      </p:grpSpPr>
+      <p:grpSpPr/>
       <p:sp>
         <p:nvSpPr>
           <p:cNvPr id="2" name="TextBox 1"/>
@@ -4568,7 +4479,6 @@
               </a:defRPr>
             </a:pPr>
             <a:r>
-              <a:rPr dirty="0"/>
               <a:t>87 salary imputation errors: Jimmy Butler showed $1.1M instead of $45.2M. Manually verified all 87.</a:t>
             </a:r>
           </a:p>
@@ -4585,16 +4495,7 @@
               </a:defRPr>
             </a:pPr>
             <a:r>
-              <a:rPr dirty="0"/>
-              <a:t>74 duplicate player-season rows: NBA API artifact. Same player selected twice on roster. Fixed with </a:t>
-            </a:r>
-            <a:r>
-              <a:rPr dirty="0" err="1"/>
-              <a:t>dedup</a:t>
-            </a:r>
-            <a:r>
-              <a:rPr dirty="0"/>
-              <a:t>.</a:t>
+              <a:t>74 duplicate player-season rows: NBA API artifact. Same player selected twice on roster. Fixed with dedup.</a:t>
             </a:r>
           </a:p>
           <a:p>
@@ -4610,7 +4511,6 @@
               </a:defRPr>
             </a:pPr>
             <a:r>
-              <a:rPr dirty="0"/>
               <a:t>Hardcoded cluster labels broke on every data change: Jokic labeled 'Bench Player'. Fixed with dynamic centroid labeling.</a:t>
             </a:r>
           </a:p>
@@ -4627,7 +4527,6 @@
               </a:defRPr>
             </a:pPr>
             <a:r>
-              <a:rPr dirty="0"/>
               <a:t>Non-shooters passed 3PT constraint: FG3% neutralization set Gobert to league avg, making him a 'shooter'. Fixed with IS_SHOOTER flag.</a:t>
             </a:r>
           </a:p>
@@ -4644,7 +4543,6 @@
               </a:defRPr>
             </a:pPr>
             <a:r>
-              <a:rPr dirty="0"/>
               <a:t>Stale archetype name 'Two-Way Guard': optimizer constraint silently matched 0 players. Renamed to 'Versatile Scorer'.</a:t>
             </a:r>
           </a:p>
@@ -4661,7 +4559,6 @@
               </a:defRPr>
             </a:pPr>
             <a:r>
-              <a:rPr dirty="0"/>
               <a:t>Equal PCA weights: LaMelo ranked #4 over Embiid. Fixed with variance-explained weighting.</a:t>
             </a:r>
           </a:p>
@@ -4678,7 +4575,6 @@
               </a:defRPr>
             </a:pPr>
             <a:r>
-              <a:rPr dirty="0"/>
               <a:t>Stale methodology text: dashboard described old approach. Corrected.</a:t>
             </a:r>
           </a:p>
@@ -4694,7 +4590,6 @@
                 <a:latin typeface="Calibri"/>
               </a:defRPr>
             </a:pPr>
-            <a:endParaRPr dirty="0"/>
           </a:p>
           <a:p>
             <a:pPr>
@@ -4709,7 +4604,6 @@
               </a:defRPr>
             </a:pPr>
             <a:r>
-              <a:rPr dirty="0"/>
               <a:t>AUTOMATED VERIFICATION: 175 checks across all pipeline outputs — all passing.</a:t>
             </a:r>
           </a:p>
@@ -4724,7 +4618,7 @@
 </file>
 
 <file path=ppt/slides/slide16.xml><?xml version="1.0" encoding="utf-8"?>
-<p:sld xmlns:a="http://schemas.openxmlformats.org/drawingml/2006/main" xmlns:r="http://schemas.openxmlformats.org/officeDocument/2006/relationships" xmlns:p="http://schemas.openxmlformats.org/presentationml/2006/main">
+<p:sld xmlns:a="http://schemas.openxmlformats.org/drawingml/2006/main" xmlns:p="http://schemas.openxmlformats.org/presentationml/2006/main" xmlns:r="http://schemas.openxmlformats.org/officeDocument/2006/relationships">
   <p:cSld>
     <p:bg>
       <p:bgPr>
@@ -4740,14 +4634,7 @@
         <p:cNvGrpSpPr/>
         <p:nvPr/>
       </p:nvGrpSpPr>
-      <p:grpSpPr>
-        <a:xfrm>
-          <a:off x="0" y="0"/>
-          <a:ext cx="0" cy="0"/>
-          <a:chOff x="0" y="0"/>
-          <a:chExt cx="0" cy="0"/>
-        </a:xfrm>
-      </p:grpSpPr>
+      <p:grpSpPr/>
       <p:sp>
         <p:nvSpPr>
           <p:cNvPr id="2" name="TextBox 1"/>
@@ -4833,7 +4720,6 @@
                 <a:latin typeface="Calibri"/>
               </a:defRPr>
             </a:pPr>
-            <a:endParaRPr/>
           </a:p>
           <a:p>
             <a:pPr>
@@ -4879,7 +4765,6 @@
                 <a:latin typeface="Calibri"/>
               </a:defRPr>
             </a:pPr>
-            <a:endParaRPr/>
           </a:p>
           <a:p>
             <a:pPr>
@@ -4925,7 +4810,6 @@
                 <a:latin typeface="Calibri"/>
               </a:defRPr>
             </a:pPr>
-            <a:endParaRPr/>
           </a:p>
           <a:p>
             <a:pPr>
@@ -4971,7 +4855,6 @@
                 <a:latin typeface="Calibri"/>
               </a:defRPr>
             </a:pPr>
-            <a:endParaRPr/>
           </a:p>
           <a:p>
             <a:pPr>
@@ -5016,7 +4899,7 @@
 </file>
 
 <file path=ppt/slides/slide17.xml><?xml version="1.0" encoding="utf-8"?>
-<p:sld xmlns:a="http://schemas.openxmlformats.org/drawingml/2006/main" xmlns:r="http://schemas.openxmlformats.org/officeDocument/2006/relationships" xmlns:p="http://schemas.openxmlformats.org/presentationml/2006/main">
+<p:sld xmlns:a="http://schemas.openxmlformats.org/drawingml/2006/main" xmlns:p="http://schemas.openxmlformats.org/presentationml/2006/main" xmlns:r="http://schemas.openxmlformats.org/officeDocument/2006/relationships">
   <p:cSld>
     <p:bg>
       <p:bgPr>
@@ -5032,14 +4915,7 @@
         <p:cNvGrpSpPr/>
         <p:nvPr/>
       </p:nvGrpSpPr>
-      <p:grpSpPr>
-        <a:xfrm>
-          <a:off x="0" y="0"/>
-          <a:ext cx="0" cy="0"/>
-          <a:chOff x="0" y="0"/>
-          <a:chExt cx="0" cy="0"/>
-        </a:xfrm>
-      </p:grpSpPr>
+      <p:grpSpPr/>
       <p:sp>
         <p:nvSpPr>
           <p:cNvPr id="2" name="TextBox 1"/>
@@ -5186,7 +5062,6 @@
               <a:t>09_verify_pipeline       175 automated checks — all passing</a:t>
             </a:r>
             <a:br/>
-            <a:endParaRPr/>
           </a:p>
         </p:txBody>
       </p:sp>
@@ -5199,7 +5074,7 @@
 </file>
 
 <file path=ppt/slides/slide18.xml><?xml version="1.0" encoding="utf-8"?>
-<p:sld xmlns:a="http://schemas.openxmlformats.org/drawingml/2006/main" xmlns:r="http://schemas.openxmlformats.org/officeDocument/2006/relationships" xmlns:p="http://schemas.openxmlformats.org/presentationml/2006/main">
+<p:sld xmlns:a="http://schemas.openxmlformats.org/drawingml/2006/main" xmlns:p="http://schemas.openxmlformats.org/presentationml/2006/main" xmlns:r="http://schemas.openxmlformats.org/officeDocument/2006/relationships">
   <p:cSld>
     <p:bg>
       <p:bgPr>
@@ -5215,14 +5090,7 @@
         <p:cNvGrpSpPr/>
         <p:nvPr/>
       </p:nvGrpSpPr>
-      <p:grpSpPr>
-        <a:xfrm>
-          <a:off x="0" y="0"/>
-          <a:ext cx="0" cy="0"/>
-          <a:chOff x="0" y="0"/>
-          <a:chExt cx="0" cy="0"/>
-        </a:xfrm>
-      </p:grpSpPr>
+      <p:grpSpPr/>
       <p:sp>
         <p:nvSpPr>
           <p:cNvPr id="2" name="TextBox 1"/>
@@ -5435,7 +5303,7 @@
 </file>
 
 <file path=ppt/slides/slide19.xml><?xml version="1.0" encoding="utf-8"?>
-<p:sld xmlns:a="http://schemas.openxmlformats.org/drawingml/2006/main" xmlns:r="http://schemas.openxmlformats.org/officeDocument/2006/relationships" xmlns:p="http://schemas.openxmlformats.org/presentationml/2006/main">
+<p:sld xmlns:a="http://schemas.openxmlformats.org/drawingml/2006/main" xmlns:p="http://schemas.openxmlformats.org/presentationml/2006/main" xmlns:r="http://schemas.openxmlformats.org/officeDocument/2006/relationships">
   <p:cSld>
     <p:bg>
       <p:bgPr>
@@ -5451,14 +5319,7 @@
         <p:cNvGrpSpPr/>
         <p:nvPr/>
       </p:nvGrpSpPr>
-      <p:grpSpPr>
-        <a:xfrm>
-          <a:off x="0" y="0"/>
-          <a:ext cx="0" cy="0"/>
-          <a:chOff x="0" y="0"/>
-          <a:chExt cx="0" cy="0"/>
-        </a:xfrm>
-      </p:grpSpPr>
+      <p:grpSpPr/>
       <p:sp>
         <p:nvSpPr>
           <p:cNvPr id="2" name="TextBox 1"/>
@@ -5526,7 +5387,7 @@
               </a:defRPr>
             </a:pPr>
             <a:r>
-              <a:t>1,185 players scored  |  175 automated checks passed  |  10 optimized rosters</a:t>
+              <a:t>1,208 players scored  |  175 automated checks passed  |  10 optimized rosters</a:t>
             </a:r>
           </a:p>
         </p:txBody>
@@ -5562,7 +5423,7 @@
               </a:defRPr>
             </a:pPr>
             <a:r>
-              <a:t>Public data. Zero bias. Mathematically proven optimal.</a:t>
+              <a:t>Public data. Data-driven, not gut-driven. Mathematically optimized.</a:t>
             </a:r>
           </a:p>
         </p:txBody>
@@ -5576,7 +5437,7 @@
 </file>
 
 <file path=ppt/slides/slide2.xml><?xml version="1.0" encoding="utf-8"?>
-<p:sld xmlns:a="http://schemas.openxmlformats.org/drawingml/2006/main" xmlns:r="http://schemas.openxmlformats.org/officeDocument/2006/relationships" xmlns:p="http://schemas.openxmlformats.org/presentationml/2006/main">
+<p:sld xmlns:a="http://schemas.openxmlformats.org/drawingml/2006/main" xmlns:p="http://schemas.openxmlformats.org/presentationml/2006/main" xmlns:r="http://schemas.openxmlformats.org/officeDocument/2006/relationships">
   <p:cSld>
     <p:bg>
       <p:bgPr>
@@ -5592,14 +5453,7 @@
         <p:cNvGrpSpPr/>
         <p:nvPr/>
       </p:nvGrpSpPr>
-      <p:grpSpPr>
-        <a:xfrm>
-          <a:off x="0" y="0"/>
-          <a:ext cx="0" cy="0"/>
-          <a:chOff x="0" y="0"/>
-          <a:chExt cx="0" cy="0"/>
-        </a:xfrm>
-      </p:grpSpPr>
+      <p:grpSpPr/>
       <p:sp>
         <p:nvSpPr>
           <p:cNvPr id="2" name="TextBox 1"/>
@@ -5733,7 +5587,6 @@
                 <a:latin typeface="Calibri"/>
               </a:defRPr>
             </a:pPr>
-            <a:endParaRPr/>
           </a:p>
           <a:p>
             <a:pPr>
@@ -5764,7 +5617,7 @@
               </a:defRPr>
             </a:pPr>
             <a:r>
-              <a:t>under a real salary cap constraint, using only publicly available data and zero human bias.</a:t>
+              <a:t>under a real salary cap constraint, using only publicly available data, with scoring weights derived from data rather than human guesswork.</a:t>
             </a:r>
           </a:p>
         </p:txBody>
@@ -5778,7 +5631,7 @@
 </file>
 
 <file path=ppt/slides/slide3.xml><?xml version="1.0" encoding="utf-8"?>
-<p:sld xmlns:a="http://schemas.openxmlformats.org/drawingml/2006/main" xmlns:r="http://schemas.openxmlformats.org/officeDocument/2006/relationships" xmlns:p="http://schemas.openxmlformats.org/presentationml/2006/main">
+<p:sld xmlns:a="http://schemas.openxmlformats.org/drawingml/2006/main" xmlns:p="http://schemas.openxmlformats.org/presentationml/2006/main" xmlns:r="http://schemas.openxmlformats.org/officeDocument/2006/relationships">
   <p:cSld>
     <p:bg>
       <p:bgPr>
@@ -5794,14 +5647,7 @@
         <p:cNvGrpSpPr/>
         <p:nvPr/>
       </p:nvGrpSpPr>
-      <p:grpSpPr>
-        <a:xfrm>
-          <a:off x="0" y="0"/>
-          <a:ext cx="0" cy="0"/>
-          <a:chOff x="0" y="0"/>
-          <a:chExt cx="0" cy="0"/>
-        </a:xfrm>
-      </p:grpSpPr>
+      <p:grpSpPr/>
       <p:sp>
         <p:nvSpPr>
           <p:cNvPr id="2" name="TextBox 1"/>
@@ -5888,7 +5734,7 @@
               </a:defRPr>
             </a:pPr>
             <a:r>
-              <a:t>3 seasons: 2021-22, 2022-23, 2023-24 (~400 players per season = 1,185 player-seasons)</a:t>
+              <a:t>3 seasons: 2021-22, 2022-23, 2023-24 (~400 players per season = 1,208 player-seasons)</a:t>
             </a:r>
           </a:p>
           <a:p>
@@ -5982,7 +5828,7 @@
 </file>
 
 <file path=ppt/slides/slide4.xml><?xml version="1.0" encoding="utf-8"?>
-<p:sld xmlns:a="http://schemas.openxmlformats.org/drawingml/2006/main" xmlns:r="http://schemas.openxmlformats.org/officeDocument/2006/relationships" xmlns:p="http://schemas.openxmlformats.org/presentationml/2006/main">
+<p:sld xmlns:a="http://schemas.openxmlformats.org/drawingml/2006/main" xmlns:p="http://schemas.openxmlformats.org/presentationml/2006/main" xmlns:r="http://schemas.openxmlformats.org/officeDocument/2006/relationships">
   <p:cSld>
     <p:bg>
       <p:bgPr>
@@ -5998,14 +5844,7 @@
         <p:cNvGrpSpPr/>
         <p:nvPr/>
       </p:nvGrpSpPr>
-      <p:grpSpPr>
-        <a:xfrm>
-          <a:off x="0" y="0"/>
-          <a:ext cx="0" cy="0"/>
-          <a:chOff x="0" y="0"/>
-          <a:chExt cx="0" cy="0"/>
-        </a:xfrm>
-      </p:grpSpPr>
+      <p:grpSpPr/>
       <p:sp>
         <p:nvSpPr>
           <p:cNvPr id="2" name="TextBox 1"/>
@@ -6170,7 +6009,7 @@
 </file>
 
 <file path=ppt/slides/slide5.xml><?xml version="1.0" encoding="utf-8"?>
-<p:sld xmlns:a="http://schemas.openxmlformats.org/drawingml/2006/main" xmlns:r="http://schemas.openxmlformats.org/officeDocument/2006/relationships" xmlns:p="http://schemas.openxmlformats.org/presentationml/2006/main">
+<p:sld xmlns:a="http://schemas.openxmlformats.org/drawingml/2006/main" xmlns:p="http://schemas.openxmlformats.org/presentationml/2006/main" xmlns:r="http://schemas.openxmlformats.org/officeDocument/2006/relationships">
   <p:cSld>
     <p:bg>
       <p:bgPr>
@@ -6186,14 +6025,7 @@
         <p:cNvGrpSpPr/>
         <p:nvPr/>
       </p:nvGrpSpPr>
-      <p:grpSpPr>
-        <a:xfrm>
-          <a:off x="0" y="0"/>
-          <a:ext cx="0" cy="0"/>
-          <a:chOff x="0" y="0"/>
-          <a:chExt cx="0" cy="0"/>
-        </a:xfrm>
-      </p:grpSpPr>
+      <p:grpSpPr/>
       <p:sp>
         <p:nvSpPr>
           <p:cNvPr id="2" name="TextBox 1"/>
@@ -6359,7 +6191,6 @@
                 <a:latin typeface="Calibri"/>
               </a:defRPr>
             </a:pPr>
-            <a:endParaRPr/>
           </a:p>
           <a:p>
             <a:pPr>
@@ -6388,7 +6219,7 @@
 </file>
 
 <file path=ppt/slides/slide6.xml><?xml version="1.0" encoding="utf-8"?>
-<p:sld xmlns:a="http://schemas.openxmlformats.org/drawingml/2006/main" xmlns:r="http://schemas.openxmlformats.org/officeDocument/2006/relationships" xmlns:p="http://schemas.openxmlformats.org/presentationml/2006/main">
+<p:sld xmlns:a="http://schemas.openxmlformats.org/drawingml/2006/main" xmlns:p="http://schemas.openxmlformats.org/presentationml/2006/main" xmlns:r="http://schemas.openxmlformats.org/officeDocument/2006/relationships">
   <p:cSld>
     <p:bg>
       <p:bgPr>
@@ -6404,14 +6235,7 @@
         <p:cNvGrpSpPr/>
         <p:nvPr/>
       </p:nvGrpSpPr>
-      <p:grpSpPr>
-        <a:xfrm>
-          <a:off x="0" y="0"/>
-          <a:ext cx="0" cy="0"/>
-          <a:chOff x="0" y="0"/>
-          <a:chExt cx="0" cy="0"/>
-        </a:xfrm>
-      </p:grpSpPr>
+      <p:grpSpPr/>
       <p:sp>
         <p:nvSpPr>
           <p:cNvPr id="2" name="TextBox 1"/>
@@ -6517,7 +6341,7 @@
 </file>
 
 <file path=ppt/slides/slide7.xml><?xml version="1.0" encoding="utf-8"?>
-<p:sld xmlns:a="http://schemas.openxmlformats.org/drawingml/2006/main" xmlns:r="http://schemas.openxmlformats.org/officeDocument/2006/relationships" xmlns:p="http://schemas.openxmlformats.org/presentationml/2006/main">
+<p:sld xmlns:a="http://schemas.openxmlformats.org/drawingml/2006/main" xmlns:p="http://schemas.openxmlformats.org/presentationml/2006/main" xmlns:r="http://schemas.openxmlformats.org/officeDocument/2006/relationships">
   <p:cSld>
     <p:bg>
       <p:bgPr>
@@ -6533,14 +6357,7 @@
         <p:cNvGrpSpPr/>
         <p:nvPr/>
       </p:nvGrpSpPr>
-      <p:grpSpPr>
-        <a:xfrm>
-          <a:off x="0" y="0"/>
-          <a:ext cx="0" cy="0"/>
-          <a:chOff x="0" y="0"/>
-          <a:chExt cx="0" cy="0"/>
-        </a:xfrm>
-      </p:grpSpPr>
+      <p:grpSpPr/>
       <p:sp>
         <p:nvSpPr>
           <p:cNvPr id="2" name="TextBox 1"/>
@@ -6689,7 +6506,7 @@
 </file>
 
 <file path=ppt/slides/slide8.xml><?xml version="1.0" encoding="utf-8"?>
-<p:sld xmlns:a="http://schemas.openxmlformats.org/drawingml/2006/main" xmlns:r="http://schemas.openxmlformats.org/officeDocument/2006/relationships" xmlns:p="http://schemas.openxmlformats.org/presentationml/2006/main">
+<p:sld xmlns:a="http://schemas.openxmlformats.org/drawingml/2006/main" xmlns:p="http://schemas.openxmlformats.org/presentationml/2006/main" xmlns:r="http://schemas.openxmlformats.org/officeDocument/2006/relationships">
   <p:cSld>
     <p:bg>
       <p:bgPr>
@@ -6705,14 +6522,7 @@
         <p:cNvGrpSpPr/>
         <p:nvPr/>
       </p:nvGrpSpPr>
-      <p:grpSpPr>
-        <a:xfrm>
-          <a:off x="0" y="0"/>
-          <a:ext cx="0" cy="0"/>
-          <a:chOff x="0" y="0"/>
-          <a:chExt cx="0" cy="0"/>
-        </a:xfrm>
-      </p:grpSpPr>
+      <p:grpSpPr/>
       <p:sp>
         <p:nvSpPr>
           <p:cNvPr id="2" name="TextBox 1"/>
@@ -6859,7 +6669,6 @@
               <a:t>20. Jusuf Nurkić                 66.8</a:t>
             </a:r>
             <a:br/>
-            <a:endParaRPr/>
           </a:p>
         </p:txBody>
       </p:sp>
@@ -6896,7 +6705,7 @@
 </file>
 
 <file path=ppt/slides/slide9.xml><?xml version="1.0" encoding="utf-8"?>
-<p:sld xmlns:a="http://schemas.openxmlformats.org/drawingml/2006/main" xmlns:r="http://schemas.openxmlformats.org/officeDocument/2006/relationships" xmlns:p="http://schemas.openxmlformats.org/presentationml/2006/main">
+<p:sld xmlns:a="http://schemas.openxmlformats.org/drawingml/2006/main" xmlns:p="http://schemas.openxmlformats.org/presentationml/2006/main" xmlns:r="http://schemas.openxmlformats.org/officeDocument/2006/relationships">
   <p:cSld>
     <p:bg>
       <p:bgPr>
@@ -6912,14 +6721,7 @@
         <p:cNvGrpSpPr/>
         <p:nvPr/>
       </p:nvGrpSpPr>
-      <p:grpSpPr>
-        <a:xfrm>
-          <a:off x="0" y="0"/>
-          <a:ext cx="0" cy="0"/>
-          <a:chOff x="0" y="0"/>
-          <a:chExt cx="0" cy="0"/>
-        </a:xfrm>
-      </p:grpSpPr>
+      <p:grpSpPr/>
       <p:sp>
         <p:nvSpPr>
           <p:cNvPr id="2" name="TextBox 1"/>
@@ -6987,7 +6789,7 @@
               </a:defRPr>
             </a:pPr>
             <a:r>
-              <a:t>K-Means groups 1,185 player-seasons into clusters based on their 9-stat profiles. Players with similar statistical fingerprints land in the same group.</a:t>
+              <a:t>K-Means groups 1,208 player-seasons into clusters based on their 9-stat profiles. Players with similar statistical fingerprints land in the same group.</a:t>
             </a:r>
             <a:br/>
             <a:br/>
@@ -7018,8 +6820,8 @@
         </p:blipFill>
         <p:spPr>
           <a:xfrm>
-            <a:off x="5760719" y="914400"/>
-            <a:ext cx="5943601" cy="2812016"/>
+            <a:off x="5760720" y="365760"/>
+            <a:ext cx="5943600" cy="3017520"/>
           </a:xfrm>
           <a:prstGeom prst="rect">
             <a:avLst/>
@@ -7042,8 +6844,8 @@
         </p:blipFill>
         <p:spPr>
           <a:xfrm>
-            <a:off x="5760720" y="3726416"/>
-            <a:ext cx="5943600" cy="3131584"/>
+            <a:off x="5760720" y="3474720"/>
+            <a:ext cx="5943600" cy="3200400"/>
           </a:xfrm>
           <a:prstGeom prst="rect">
             <a:avLst/>

</xml_diff>